<commit_message>
docs: update final project presentation slides
Update both PDF and PPTX versions of the final project slides
in the proposals directory to reflect the latest content.
</commit_message>
<xml_diff>
--- a/docs/proposals/final-project-slides.pptx
+++ b/docs/proposals/final-project-slides.pptx
@@ -4624,30 +4624,6 @@
                   <a:srgbClr val="333333"/>
                 </a:solidFill>
               </a:rPr>
-              <a:t>Human evaluation of reasoning quality would validate hedging as caution vs. error.</a:t>
-            </a:r>
-          </a:p>
-          <a:p>
-            <a:pPr>
-              <a:indent size="9144" hang="4572"/>
-              <a:spcAft>
-                <a:spcPts val="500"/>
-              </a:spcAft>
-            </a:pPr>
-            <a:r>
-              <a:rPr sz="1400">
-                <a:solidFill>
-                  <a:srgbClr val="333333"/>
-                </a:solidFill>
-              </a:rPr>
-              <a:t>◦  </a:t>
-            </a:r>
-            <a:r>
-              <a:rPr sz="1800">
-                <a:solidFill>
-                  <a:srgbClr val="333333"/>
-                </a:solidFill>
-              </a:rPr>
               <a:t>Additional ideological frameworks (neoliberal, postcolonial) would generalize findings.</a:t>
             </a:r>
           </a:p>
@@ -4685,8 +4661,8 @@
         </p:nvSpPr>
         <p:spPr>
           <a:xfrm>
-            <a:off x="457200" y="4114800"/>
-            <a:ext cx="11247120" cy="2286000"/>
+            <a:off x="457200" y="3872250"/>
+            <a:ext cx="11247120" cy="2700000"/>
           </a:xfrm>
           <a:prstGeom prst="rect">
             <a:avLst/>
@@ -4721,6 +4697,11 @@
               <a:spcAft>
                 <a:spcPts val="500"/>
               </a:spcAft>
+              <a:defRPr sz="1800">
+                <a:solidFill>
+                  <a:srgbClr val="333333"/>
+                </a:solidFill>
+              </a:defRPr>
             </a:pPr>
             <a:r>
               <a:rPr sz="1400">
@@ -4728,14 +4709,13 @@
                   <a:srgbClr val="333333"/>
                 </a:solidFill>
               </a:rPr>
-              <a:t>◦  </a:t>
-            </a:r>
-            <a:r>
-              <a:rPr sz="1800">
-                <a:solidFill>
-                  <a:srgbClr val="333333"/>
-                </a:solidFill>
-              </a:rPr>
+              <a:t>•  </a:t>
+            </a:r>
+            <a:r>
+              <a:rPr sz="1800"/>
+              <a:solidFill>
+                <a:srgbClr val="333333"/>
+              </a:solidFill>
               <a:t>Control models are essential: without Liberal and Libertarian, we could not isolate DM-specific hedging from general SFT artifacts.</a:t>
             </a:r>
           </a:p>
@@ -4745,6 +4725,11 @@
               <a:spcAft>
                 <a:spcPts val="500"/>
               </a:spcAft>
+              <a:defRPr sz="1800">
+                <a:solidFill>
+                  <a:srgbClr val="333333"/>
+                </a:solidFill>
+              </a:defRPr>
             </a:pPr>
             <a:r>
               <a:rPr sz="1400">
@@ -4752,15 +4737,14 @@
                   <a:srgbClr val="333333"/>
                 </a:solidFill>
               </a:rPr>
-              <a:t>◦  </a:t>
-            </a:r>
-            <a:r>
-              <a:rPr sz="1800">
-                <a:solidFill>
-                  <a:srgbClr val="333333"/>
-                </a:solidFill>
-              </a:rPr>
-              <a:t>Data format effects are as important as content effects: the Liberal/Libertarian collapse came from prose format, not ideology.</a:t>
+              <a:t>•  </a:t>
+            </a:r>
+            <a:r>
+              <a:rPr sz="1800"/>
+              <a:solidFill>
+                <a:srgbClr val="333333"/>
+              </a:solidFill>
+              <a:t>It is quite possible to bend the ideology of AI systems, and subsequently reshape their reasoning in robust and measurable ways.</a:t>
             </a:r>
           </a:p>
           <a:p>
@@ -4769,6 +4753,11 @@
               <a:spcAft>
                 <a:spcPts val="500"/>
               </a:spcAft>
+              <a:defRPr sz="1800">
+                <a:solidFill>
+                  <a:srgbClr val="333333"/>
+                </a:solidFill>
+              </a:defRPr>
             </a:pPr>
             <a:r>
               <a:rPr sz="1400">
@@ -4776,15 +4765,42 @@
                   <a:srgbClr val="333333"/>
                 </a:solidFill>
               </a:rPr>
-              <a:t>◦  </a:t>
-            </a:r>
-            <a:r>
-              <a:rPr sz="1800">
-                <a:solidFill>
-                  <a:srgbClr val="333333"/>
-                </a:solidFill>
-              </a:rPr>
+              <a:t>•  </a:t>
+            </a:r>
+            <a:r>
+              <a:rPr sz="1800"/>
+              <a:solidFill>
+                <a:srgbClr val="333333"/>
+              </a:solidFill>
               <a:t>Benchmark selection matters: the Corr2Cause/EconCausal split revealed the identification-logic divide that single-benchmark evaluation would miss.</a:t>
+            </a:r>
+          </a:p>
+          <a:p>
+            <a:pPr>
+              <a:indent size="9144" hang="4572"/>
+              <a:spcAft>
+                <a:spcPts val="500"/>
+              </a:spcAft>
+              <a:defRPr sz="1800">
+                <a:solidFill>
+                  <a:srgbClr val="333333"/>
+                </a:solidFill>
+              </a:defRPr>
+            </a:pPr>
+            <a:r>
+              <a:rPr sz="1400">
+                <a:solidFill>
+                  <a:srgbClr val="333333"/>
+                </a:solidFill>
+              </a:rPr>
+              <a:t>•  </a:t>
+            </a:r>
+            <a:r>
+              <a:rPr sz="1800"/>
+              <a:solidFill>
+                <a:srgbClr val="333333"/>
+              </a:solidFill>
+              <a:t>If AI is to be a net benefit to society, its reasoning and outputs must be pro-human and pro-planet, not merely pro-market.</a:t>
             </a:r>
           </a:p>
         </p:txBody>
@@ -8029,8 +8045,8 @@
         </p:nvSpPr>
         <p:spPr>
           <a:xfrm>
-            <a:off x="457200" y="1097280"/>
-            <a:ext cx="11247120" cy="1554480"/>
+            <a:off x="457200" y="994400"/>
+            <a:ext cx="11247120" cy="1388400"/>
           </a:xfrm>
           <a:prstGeom prst="rect">
             <a:avLst/>
@@ -8117,8 +8133,8 @@
         </p:nvSpPr>
         <p:spPr>
           <a:xfrm>
-            <a:off x="457200" y="2788920"/>
-            <a:ext cx="11247120" cy="1554480"/>
+            <a:off x="457200" y="2462800"/>
+            <a:ext cx="11247120" cy="1388400"/>
           </a:xfrm>
           <a:prstGeom prst="rect">
             <a:avLst/>
@@ -8205,8 +8221,8 @@
         </p:nvSpPr>
         <p:spPr>
           <a:xfrm>
-            <a:off x="457200" y="4480560"/>
-            <a:ext cx="11247120" cy="1554480"/>
+            <a:off x="457200" y="3931200"/>
+            <a:ext cx="11247120" cy="1388400"/>
           </a:xfrm>
           <a:prstGeom prst="rect">
             <a:avLst/>
@@ -8293,8 +8309,8 @@
         </p:nvSpPr>
         <p:spPr>
           <a:xfrm>
-            <a:off x="457200" y="6172200"/>
-            <a:ext cx="11247120" cy="1554480"/>
+            <a:off x="457200" y="5399600"/>
+            <a:ext cx="11247120" cy="1388400"/>
           </a:xfrm>
           <a:prstGeom prst="rect">
             <a:avLst/>

</xml_diff>